<commit_message>
Update presentation and add new image
Modified the 2025 presentation file and added a new PNG image to the Document directory.
</commit_message>
<xml_diff>
--- a/Document/2025경진대회 패널 배포-고등.pptx
+++ b/Document/2025경진대회 패널 배포-고등.pptx
@@ -254,7 +254,7 @@
           <a:p>
             <a:fld id="{CBF1DC50-C5CA-44B4-A558-6C26647E5902}" type="datetimeFigureOut">
               <a:rPr lang="ko-KR" altLang="en-US" smtClean="0"/>
-              <a:t>2025-10-28</a:t>
+              <a:t>2025-11-02</a:t>
             </a:fld>
             <a:endParaRPr lang="ko-KR" altLang="en-US"/>
           </a:p>
@@ -511,7 +511,7 @@
           <a:p>
             <a:fld id="{CBF1DC50-C5CA-44B4-A558-6C26647E5902}" type="datetimeFigureOut">
               <a:rPr lang="ko-KR" altLang="en-US" smtClean="0"/>
-              <a:t>2025-10-28</a:t>
+              <a:t>2025-11-02</a:t>
             </a:fld>
             <a:endParaRPr lang="ko-KR" altLang="en-US"/>
           </a:p>
@@ -681,7 +681,7 @@
           <a:p>
             <a:fld id="{CBF1DC50-C5CA-44B4-A558-6C26647E5902}" type="datetimeFigureOut">
               <a:rPr lang="ko-KR" altLang="en-US" smtClean="0"/>
-              <a:t>2025-10-28</a:t>
+              <a:t>2025-11-02</a:t>
             </a:fld>
             <a:endParaRPr lang="ko-KR" altLang="en-US"/>
           </a:p>
@@ -861,7 +861,7 @@
           <a:p>
             <a:fld id="{CBF1DC50-C5CA-44B4-A558-6C26647E5902}" type="datetimeFigureOut">
               <a:rPr lang="ko-KR" altLang="en-US" smtClean="0"/>
-              <a:t>2025-10-28</a:t>
+              <a:t>2025-11-02</a:t>
             </a:fld>
             <a:endParaRPr lang="ko-KR" altLang="en-US"/>
           </a:p>
@@ -1031,7 +1031,7 @@
           <a:p>
             <a:fld id="{CBF1DC50-C5CA-44B4-A558-6C26647E5902}" type="datetimeFigureOut">
               <a:rPr lang="ko-KR" altLang="en-US" smtClean="0"/>
-              <a:t>2025-10-28</a:t>
+              <a:t>2025-11-02</a:t>
             </a:fld>
             <a:endParaRPr lang="ko-KR" altLang="en-US"/>
           </a:p>
@@ -1275,7 +1275,7 @@
           <a:p>
             <a:fld id="{CBF1DC50-C5CA-44B4-A558-6C26647E5902}" type="datetimeFigureOut">
               <a:rPr lang="ko-KR" altLang="en-US" smtClean="0"/>
-              <a:t>2025-10-28</a:t>
+              <a:t>2025-11-02</a:t>
             </a:fld>
             <a:endParaRPr lang="ko-KR" altLang="en-US"/>
           </a:p>
@@ -1507,7 +1507,7 @@
           <a:p>
             <a:fld id="{CBF1DC50-C5CA-44B4-A558-6C26647E5902}" type="datetimeFigureOut">
               <a:rPr lang="ko-KR" altLang="en-US" smtClean="0"/>
-              <a:t>2025-10-28</a:t>
+              <a:t>2025-11-02</a:t>
             </a:fld>
             <a:endParaRPr lang="ko-KR" altLang="en-US"/>
           </a:p>
@@ -1874,7 +1874,7 @@
           <a:p>
             <a:fld id="{CBF1DC50-C5CA-44B4-A558-6C26647E5902}" type="datetimeFigureOut">
               <a:rPr lang="ko-KR" altLang="en-US" smtClean="0"/>
-              <a:t>2025-10-28</a:t>
+              <a:t>2025-11-02</a:t>
             </a:fld>
             <a:endParaRPr lang="ko-KR" altLang="en-US"/>
           </a:p>
@@ -1992,7 +1992,7 @@
           <a:p>
             <a:fld id="{CBF1DC50-C5CA-44B4-A558-6C26647E5902}" type="datetimeFigureOut">
               <a:rPr lang="ko-KR" altLang="en-US" smtClean="0"/>
-              <a:t>2025-10-28</a:t>
+              <a:t>2025-11-02</a:t>
             </a:fld>
             <a:endParaRPr lang="ko-KR" altLang="en-US"/>
           </a:p>
@@ -2087,7 +2087,7 @@
           <a:p>
             <a:fld id="{CBF1DC50-C5CA-44B4-A558-6C26647E5902}" type="datetimeFigureOut">
               <a:rPr lang="ko-KR" altLang="en-US" smtClean="0"/>
-              <a:t>2025-10-28</a:t>
+              <a:t>2025-11-02</a:t>
             </a:fld>
             <a:endParaRPr lang="ko-KR" altLang="en-US"/>
           </a:p>
@@ -2182,7 +2182,7 @@
           <a:p>
             <a:fld id="{CBF1DC50-C5CA-44B4-A558-6C26647E5902}" type="datetimeFigureOut">
               <a:rPr lang="ko-KR" altLang="en-US" smtClean="0"/>
-              <a:t>2025-10-28</a:t>
+              <a:t>2025-11-02</a:t>
             </a:fld>
             <a:endParaRPr lang="ko-KR" altLang="en-US"/>
           </a:p>
@@ -2489,7 +2489,7 @@
           <a:p>
             <a:fld id="{CBF1DC50-C5CA-44B4-A558-6C26647E5902}" type="datetimeFigureOut">
               <a:rPr lang="ko-KR" altLang="en-US" smtClean="0"/>
-              <a:t>2025-10-28</a:t>
+              <a:t>2025-11-02</a:t>
             </a:fld>
             <a:endParaRPr lang="ko-KR" altLang="en-US"/>
           </a:p>
@@ -2702,7 +2702,7 @@
           <a:p>
             <a:fld id="{CBF1DC50-C5CA-44B4-A558-6C26647E5902}" type="datetimeFigureOut">
               <a:rPr lang="ko-KR" altLang="en-US" smtClean="0"/>
-              <a:t>2025-10-28</a:t>
+              <a:t>2025-11-02</a:t>
             </a:fld>
             <a:endParaRPr lang="ko-KR" altLang="en-US"/>
           </a:p>
@@ -4007,6 +4007,42 @@
           </p:txBody>
         </p:sp>
       </p:grpSp>
+      <p:pic>
+        <p:nvPicPr>
+          <p:cNvPr id="11" name="그림 10" descr="도표, 텍스트, 스크린샷, 라인이(가) 표시된 사진">
+            <a:extLst>
+              <a:ext uri="{FF2B5EF4-FFF2-40B4-BE49-F238E27FC236}">
+                <a16:creationId xmlns:a16="http://schemas.microsoft.com/office/drawing/2014/main" id="{6E92F880-E02E-5AD8-A3CA-132040BA1027}"/>
+              </a:ext>
+            </a:extLst>
+          </p:cNvPr>
+          <p:cNvPicPr>
+            <a:picLocks noChangeAspect="1"/>
+          </p:cNvPicPr>
+          <p:nvPr/>
+        </p:nvPicPr>
+        <p:blipFill>
+          <a:blip r:embed="rId4">
+            <a:extLst>
+              <a:ext uri="{28A0092B-C50C-407E-A947-70E740481C1C}">
+                <a14:useLocalDpi xmlns:a14="http://schemas.microsoft.com/office/drawing/2010/main" val="0"/>
+              </a:ext>
+            </a:extLst>
+          </a:blip>
+          <a:stretch>
+            <a:fillRect/>
+          </a:stretch>
+        </p:blipFill>
+        <p:spPr>
+          <a:xfrm>
+            <a:off x="987631" y="19482258"/>
+            <a:ext cx="21758620" cy="7439823"/>
+          </a:xfrm>
+          <a:prstGeom prst="rect">
+            <a:avLst/>
+          </a:prstGeom>
+        </p:spPr>
+      </p:pic>
     </p:spTree>
     <p:extLst>
       <p:ext uri="{BB962C8B-B14F-4D97-AF65-F5344CB8AC3E}">

</xml_diff>

<commit_message>
Remove main.html and update index.html formatting
Deleted Source/main.html and cleaned up trailing blank lines in Source/power-korea-now-4a04115a/index.html. Also updated the PPTX document in Document directory.
</commit_message>
<xml_diff>
--- a/Document/2025경진대회 패널 배포-고등.pptx
+++ b/Document/2025경진대회 패널 배포-고등.pptx
@@ -254,7 +254,7 @@
           <a:p>
             <a:fld id="{CBF1DC50-C5CA-44B4-A558-6C26647E5902}" type="datetimeFigureOut">
               <a:rPr lang="ko-KR" altLang="en-US" smtClean="0"/>
-              <a:t>2025-11-06</a:t>
+              <a:t>2025-11-08</a:t>
             </a:fld>
             <a:endParaRPr lang="ko-KR" altLang="en-US"/>
           </a:p>
@@ -511,7 +511,7 @@
           <a:p>
             <a:fld id="{CBF1DC50-C5CA-44B4-A558-6C26647E5902}" type="datetimeFigureOut">
               <a:rPr lang="ko-KR" altLang="en-US" smtClean="0"/>
-              <a:t>2025-11-06</a:t>
+              <a:t>2025-11-08</a:t>
             </a:fld>
             <a:endParaRPr lang="ko-KR" altLang="en-US"/>
           </a:p>
@@ -681,7 +681,7 @@
           <a:p>
             <a:fld id="{CBF1DC50-C5CA-44B4-A558-6C26647E5902}" type="datetimeFigureOut">
               <a:rPr lang="ko-KR" altLang="en-US" smtClean="0"/>
-              <a:t>2025-11-06</a:t>
+              <a:t>2025-11-08</a:t>
             </a:fld>
             <a:endParaRPr lang="ko-KR" altLang="en-US"/>
           </a:p>
@@ -861,7 +861,7 @@
           <a:p>
             <a:fld id="{CBF1DC50-C5CA-44B4-A558-6C26647E5902}" type="datetimeFigureOut">
               <a:rPr lang="ko-KR" altLang="en-US" smtClean="0"/>
-              <a:t>2025-11-06</a:t>
+              <a:t>2025-11-08</a:t>
             </a:fld>
             <a:endParaRPr lang="ko-KR" altLang="en-US"/>
           </a:p>
@@ -1031,7 +1031,7 @@
           <a:p>
             <a:fld id="{CBF1DC50-C5CA-44B4-A558-6C26647E5902}" type="datetimeFigureOut">
               <a:rPr lang="ko-KR" altLang="en-US" smtClean="0"/>
-              <a:t>2025-11-06</a:t>
+              <a:t>2025-11-08</a:t>
             </a:fld>
             <a:endParaRPr lang="ko-KR" altLang="en-US"/>
           </a:p>
@@ -1275,7 +1275,7 @@
           <a:p>
             <a:fld id="{CBF1DC50-C5CA-44B4-A558-6C26647E5902}" type="datetimeFigureOut">
               <a:rPr lang="ko-KR" altLang="en-US" smtClean="0"/>
-              <a:t>2025-11-06</a:t>
+              <a:t>2025-11-08</a:t>
             </a:fld>
             <a:endParaRPr lang="ko-KR" altLang="en-US"/>
           </a:p>
@@ -1507,7 +1507,7 @@
           <a:p>
             <a:fld id="{CBF1DC50-C5CA-44B4-A558-6C26647E5902}" type="datetimeFigureOut">
               <a:rPr lang="ko-KR" altLang="en-US" smtClean="0"/>
-              <a:t>2025-11-06</a:t>
+              <a:t>2025-11-08</a:t>
             </a:fld>
             <a:endParaRPr lang="ko-KR" altLang="en-US"/>
           </a:p>
@@ -1874,7 +1874,7 @@
           <a:p>
             <a:fld id="{CBF1DC50-C5CA-44B4-A558-6C26647E5902}" type="datetimeFigureOut">
               <a:rPr lang="ko-KR" altLang="en-US" smtClean="0"/>
-              <a:t>2025-11-06</a:t>
+              <a:t>2025-11-08</a:t>
             </a:fld>
             <a:endParaRPr lang="ko-KR" altLang="en-US"/>
           </a:p>
@@ -1992,7 +1992,7 @@
           <a:p>
             <a:fld id="{CBF1DC50-C5CA-44B4-A558-6C26647E5902}" type="datetimeFigureOut">
               <a:rPr lang="ko-KR" altLang="en-US" smtClean="0"/>
-              <a:t>2025-11-06</a:t>
+              <a:t>2025-11-08</a:t>
             </a:fld>
             <a:endParaRPr lang="ko-KR" altLang="en-US"/>
           </a:p>
@@ -2087,7 +2087,7 @@
           <a:p>
             <a:fld id="{CBF1DC50-C5CA-44B4-A558-6C26647E5902}" type="datetimeFigureOut">
               <a:rPr lang="ko-KR" altLang="en-US" smtClean="0"/>
-              <a:t>2025-11-06</a:t>
+              <a:t>2025-11-08</a:t>
             </a:fld>
             <a:endParaRPr lang="ko-KR" altLang="en-US"/>
           </a:p>
@@ -2182,7 +2182,7 @@
           <a:p>
             <a:fld id="{CBF1DC50-C5CA-44B4-A558-6C26647E5902}" type="datetimeFigureOut">
               <a:rPr lang="ko-KR" altLang="en-US" smtClean="0"/>
-              <a:t>2025-11-06</a:t>
+              <a:t>2025-11-08</a:t>
             </a:fld>
             <a:endParaRPr lang="ko-KR" altLang="en-US"/>
           </a:p>
@@ -2489,7 +2489,7 @@
           <a:p>
             <a:fld id="{CBF1DC50-C5CA-44B4-A558-6C26647E5902}" type="datetimeFigureOut">
               <a:rPr lang="ko-KR" altLang="en-US" smtClean="0"/>
-              <a:t>2025-11-06</a:t>
+              <a:t>2025-11-08</a:t>
             </a:fld>
             <a:endParaRPr lang="ko-KR" altLang="en-US"/>
           </a:p>
@@ -2702,7 +2702,7 @@
           <a:p>
             <a:fld id="{CBF1DC50-C5CA-44B4-A558-6C26647E5902}" type="datetimeFigureOut">
               <a:rPr lang="ko-KR" altLang="en-US" smtClean="0"/>
-              <a:t>2025-11-06</a:t>
+              <a:t>2025-11-08</a:t>
             </a:fld>
             <a:endParaRPr lang="ko-KR" altLang="en-US"/>
           </a:p>
@@ -4423,6 +4423,36 @@
           </a:p>
         </p:txBody>
       </p:sp>
+      <p:pic>
+        <p:nvPicPr>
+          <p:cNvPr id="14" name="그림 13">
+            <a:extLst>
+              <a:ext uri="{FF2B5EF4-FFF2-40B4-BE49-F238E27FC236}">
+                <a16:creationId xmlns:a16="http://schemas.microsoft.com/office/drawing/2014/main" id="{86045430-5DED-A358-B1B6-22F85B6C1A95}"/>
+              </a:ext>
+            </a:extLst>
+          </p:cNvPr>
+          <p:cNvPicPr>
+            <a:picLocks noChangeAspect="1"/>
+          </p:cNvPicPr>
+          <p:nvPr/>
+        </p:nvPicPr>
+        <p:blipFill>
+          <a:blip r:embed="rId5"/>
+          <a:stretch>
+            <a:fillRect/>
+          </a:stretch>
+        </p:blipFill>
+        <p:spPr>
+          <a:xfrm>
+            <a:off x="10565163" y="28349969"/>
+            <a:ext cx="6569009" cy="6111770"/>
+          </a:xfrm>
+          <a:prstGeom prst="rect">
+            <a:avLst/>
+          </a:prstGeom>
+        </p:spPr>
+      </p:pic>
     </p:spTree>
     <p:extLst>
       <p:ext uri="{BB962C8B-B14F-4D97-AF65-F5344CB8AC3E}">

</xml_diff>